<commit_message>
talk: no disclosures (speaker confirmed 2026-10-13)
The congress deck's disclosure slide carries the x on "No, nothing to disclose" with an empty company
table, and the Slides deck's closing placeholder reads "Disclosures: none."

Co-Authored-By: Claude Opus 5.5 <noreply@anthropic.com>
</commit_message>
<xml_diff>
--- a/talk/deck/congress/Fridman_WSC2026_open_science.pptx
+++ b/talk/deck/congress/Fridman_WSC2026_open_science.pptx
@@ -1264,7 +1264,7 @@
           <a:lstStyle/>
           <a:p>
             <a:r>
-              <a:t>Required by the congress. Tick one box by typing an x in the blue cell, and list any company in the table. The congress's published faculty disclosure list shows Speakers Bureau, Regeneron/Bayer, under Other; confirm it, or ask wsc@kenes.com to correct it.</a:t>
+              <a:t>Nothing to disclose. Required by the congress; leave it up for a second and move on.</a:t>
             </a:r>
           </a:p>
         </p:txBody>
@@ -9990,11 +9990,11 @@
                       <a:r>
                         <a:rPr sz="1500" i="0" b="0">
                           <a:solidFill>
-                            <a:srgbClr val="000000"/>
+                            <a:srgbClr val="FFFFFF"/>
                           </a:solidFill>
                           <a:latin typeface="Arial"/>
                         </a:rPr>
-                        <a:t/>
+                        <a:t>x</a:t>
                       </a:r>
                     </a:p>
                   </a:txBody>
@@ -10078,7 +10078,7 @@
                       <a:r>
                         <a:rPr sz="1500" i="0" b="0">
                           <a:solidFill>
-                            <a:srgbClr val="000000"/>
+                            <a:srgbClr val="FFFFFF"/>
                           </a:solidFill>
                           <a:latin typeface="Arial"/>
                         </a:rPr>

</xml_diff>

<commit_message>
talk: count Charité once in the commitment ranking
The Center for Stroke Research Berlin and the Berlin Institute of Health are Charité units that OpenAlex lists
separately, so the slide showed Charité twice (5.2x and 4.4x). The talk analysis now applies
configs/institution_aliases.csv (merged from main, shared with the dashboard builder) and counts an article that
lists two units once. Recomputed from the 2026-10-13 run with the dashboard's selection (top 60 institutions by
audited articles): Charité 4.4x (133 audited articles), then Oxford 2.9x, UKE Hamburg-Eppendorf 2.6x, Edinburgh
2.5x, Stanford 2.3x, Nottingham 2.2x, Massachusetts General Hospital 2.2x, Glasgow 2.1x; Karolinska University
Hospital enters the top 60. Slide, notes, outline, table, figure and .pptx updated.

Co-Authored-By: Claude Opus 5.5 <noreply@anthropic.com>
</commit_message>
<xml_diff>
--- a/talk/deck/congress/Fridman_WSC2026_open_science.pptx
+++ b/talk/deck/congress/Fridman_WSC2026_open_science.pptx
@@ -941,7 +941,7 @@
           <a:lstStyle/>
           <a:p>
             <a:r>
-              <a:t>Forty-five seconds. The index is the mean, over three full-text signals (data deposited or public source, GitHub, trial registration), of an institution's rate divided by the stroke rate; 1 = stroke average. Shown: the top of the 60 institutions with the most audited articles (82 or more each), as on the dashboard. Small counts are a hint, not a ranking. Journals: among the 40 largest on the dashboard, the Journal of Cerebral Blood Flow and Metabolism leads (2.7x) and Stroke is fourth (1.5x); among smaller journals with at least 30 audited articles, Nature Communications, Brain Communications and PeerJ lead. The point: the measurement exists, is cheap, and is what a prize would recognise.</a:t>
+              <a:t>Forty-five seconds. The index is the mean, over three full-text signals (data deposited or public source, GitHub, trial registration), of an institution's rate divided by the stroke rate; 1 = stroke average. Shown: the top of the 60 institutions with the most audited articles (82 or more each), as on the dashboard. Charité is counted once: OpenAlex lists its Center for Stroke Research Berlin and the Berlin Institute of Health separately, and those are merged into it (133 audited articles; deposit or public source 9.8%, GitHub 10.5%, trial registration 37%). Small counts are a hint, not a ranking. Journals: among the 40 largest on the dashboard, the Journal of Cerebral Blood Flow and Metabolism leads (2.7x) and Stroke is fourth (1.5x); among smaller journals with at least 30 audited articles, Nature Communications, Brain Communications and PeerJ lead. The point: the measurement exists, is cheap, and is what a prize would recognise.</a:t>
             </a:r>
           </a:p>
         </p:txBody>
@@ -12459,8 +12459,8 @@
         </p:nvSpPr>
         <p:spPr>
           <a:xfrm>
-            <a:off x="3981450" y="1809155"/>
-            <a:ext cx="714375" cy="190500"/>
+            <a:off x="3981450" y="1818680"/>
+            <a:ext cx="714375" cy="161925"/>
           </a:xfrm>
           <a:prstGeom prst="rect">
             <a:avLst/>
@@ -12503,8 +12503,8 @@
         </p:nvSpPr>
         <p:spPr>
           <a:xfrm>
-            <a:off x="4695825" y="1809155"/>
-            <a:ext cx="3000375" cy="190500"/>
+            <a:off x="4695825" y="1818680"/>
+            <a:ext cx="2428875" cy="161925"/>
           </a:xfrm>
           <a:prstGeom prst="rect">
             <a:avLst/>
@@ -12547,8 +12547,8 @@
         </p:nvSpPr>
         <p:spPr>
           <a:xfrm>
-            <a:off x="3981450" y="2104430"/>
-            <a:ext cx="714375" cy="190500"/>
+            <a:off x="3981450" y="2075855"/>
+            <a:ext cx="714375" cy="161925"/>
           </a:xfrm>
           <a:prstGeom prst="rect">
             <a:avLst/>
@@ -12591,8 +12591,8 @@
         </p:nvSpPr>
         <p:spPr>
           <a:xfrm>
-            <a:off x="4695825" y="2104430"/>
-            <a:ext cx="2428875" cy="190500"/>
+            <a:off x="4695825" y="2075855"/>
+            <a:ext cx="1357312" cy="161925"/>
           </a:xfrm>
           <a:prstGeom prst="rect">
             <a:avLst/>
@@ -12635,8 +12635,8 @@
         </p:nvSpPr>
         <p:spPr>
           <a:xfrm>
-            <a:off x="3981450" y="2399705"/>
-            <a:ext cx="714375" cy="190500"/>
+            <a:off x="3981450" y="2333030"/>
+            <a:ext cx="714375" cy="161925"/>
           </a:xfrm>
           <a:prstGeom prst="rect">
             <a:avLst/>
@@ -12679,8 +12679,8 @@
         </p:nvSpPr>
         <p:spPr>
           <a:xfrm>
-            <a:off x="4695825" y="2399705"/>
-            <a:ext cx="1357312" cy="190500"/>
+            <a:off x="4695825" y="2333030"/>
+            <a:ext cx="1143000" cy="161925"/>
           </a:xfrm>
           <a:prstGeom prst="rect">
             <a:avLst/>
@@ -12723,8 +12723,8 @@
         </p:nvSpPr>
         <p:spPr>
           <a:xfrm>
-            <a:off x="3981450" y="2694980"/>
-            <a:ext cx="714375" cy="190500"/>
+            <a:off x="3981450" y="2590205"/>
+            <a:ext cx="714375" cy="161925"/>
           </a:xfrm>
           <a:prstGeom prst="rect">
             <a:avLst/>
@@ -12767,8 +12767,8 @@
         </p:nvSpPr>
         <p:spPr>
           <a:xfrm>
-            <a:off x="4695825" y="2694980"/>
-            <a:ext cx="1143000" cy="190500"/>
+            <a:off x="4695825" y="2590205"/>
+            <a:ext cx="1071562" cy="161925"/>
           </a:xfrm>
           <a:prstGeom prst="rect">
             <a:avLst/>
@@ -12811,8 +12811,8 @@
         </p:nvSpPr>
         <p:spPr>
           <a:xfrm>
-            <a:off x="3981450" y="2990255"/>
-            <a:ext cx="714375" cy="190500"/>
+            <a:off x="3981450" y="2847380"/>
+            <a:ext cx="714375" cy="161925"/>
           </a:xfrm>
           <a:prstGeom prst="rect">
             <a:avLst/>
@@ -12855,8 +12855,8 @@
         </p:nvSpPr>
         <p:spPr>
           <a:xfrm>
-            <a:off x="4695825" y="2990255"/>
-            <a:ext cx="1071562" cy="190500"/>
+            <a:off x="4695825" y="2847380"/>
+            <a:ext cx="928688" cy="161925"/>
           </a:xfrm>
           <a:prstGeom prst="rect">
             <a:avLst/>
@@ -12899,8 +12899,8 @@
         </p:nvSpPr>
         <p:spPr>
           <a:xfrm>
-            <a:off x="3981450" y="3285530"/>
-            <a:ext cx="714375" cy="190500"/>
+            <a:off x="3981450" y="3104555"/>
+            <a:ext cx="714375" cy="161925"/>
           </a:xfrm>
           <a:prstGeom prst="rect">
             <a:avLst/>
@@ -12943,8 +12943,8 @@
         </p:nvSpPr>
         <p:spPr>
           <a:xfrm>
-            <a:off x="4695825" y="3285530"/>
-            <a:ext cx="928688" cy="190500"/>
+            <a:off x="4695825" y="3104555"/>
+            <a:ext cx="857250" cy="161925"/>
           </a:xfrm>
           <a:prstGeom prst="rect">
             <a:avLst/>
@@ -12981,7 +12981,183 @@
       </p:sp>
       <p:sp>
         <p:nvSpPr>
-          <p:cNvPr id="17" name="TextBox 16"/>
+          <p:cNvPr id="17" name="Rectangle 16"/>
+          <p:cNvSpPr/>
+          <p:nvPr/>
+        </p:nvSpPr>
+        <p:spPr>
+          <a:xfrm>
+            <a:off x="3981450" y="3361730"/>
+            <a:ext cx="714375" cy="161925"/>
+          </a:xfrm>
+          <a:prstGeom prst="rect">
+            <a:avLst/>
+          </a:prstGeom>
+          <a:solidFill>
+            <a:srgbClr val="C8C8C4"/>
+          </a:solidFill>
+          <a:ln>
+            <a:noFill/>
+          </a:ln>
+          <a:effectLst/>
+        </p:spPr>
+        <p:style>
+          <a:lnRef idx="1">
+            <a:schemeClr val="accent1"/>
+          </a:lnRef>
+          <a:fillRef idx="3">
+            <a:schemeClr val="accent1"/>
+          </a:fillRef>
+          <a:effectRef idx="2">
+            <a:schemeClr val="accent1"/>
+          </a:effectRef>
+          <a:fontRef idx="minor">
+            <a:schemeClr val="lt1"/>
+          </a:fontRef>
+        </p:style>
+        <p:txBody>
+          <a:bodyPr rtlCol="0" anchor="ctr"/>
+          <a:lstStyle/>
+          <a:p>
+            <a:pPr algn="ctr"/>
+          </a:p>
+        </p:txBody>
+      </p:sp>
+      <p:sp>
+        <p:nvSpPr>
+          <p:cNvPr id="18" name="Rectangle 17"/>
+          <p:cNvSpPr/>
+          <p:nvPr/>
+        </p:nvSpPr>
+        <p:spPr>
+          <a:xfrm>
+            <a:off x="4695825" y="3361730"/>
+            <a:ext cx="857250" cy="161925"/>
+          </a:xfrm>
+          <a:prstGeom prst="rect">
+            <a:avLst/>
+          </a:prstGeom>
+          <a:solidFill>
+            <a:srgbClr val="D7263D"/>
+          </a:solidFill>
+          <a:ln>
+            <a:noFill/>
+          </a:ln>
+          <a:effectLst/>
+        </p:spPr>
+        <p:style>
+          <a:lnRef idx="1">
+            <a:schemeClr val="accent1"/>
+          </a:lnRef>
+          <a:fillRef idx="3">
+            <a:schemeClr val="accent1"/>
+          </a:fillRef>
+          <a:effectRef idx="2">
+            <a:schemeClr val="accent1"/>
+          </a:effectRef>
+          <a:fontRef idx="minor">
+            <a:schemeClr val="lt1"/>
+          </a:fontRef>
+        </p:style>
+        <p:txBody>
+          <a:bodyPr rtlCol="0" anchor="ctr"/>
+          <a:lstStyle/>
+          <a:p>
+            <a:pPr algn="ctr"/>
+          </a:p>
+        </p:txBody>
+      </p:sp>
+      <p:sp>
+        <p:nvSpPr>
+          <p:cNvPr id="19" name="Rectangle 18"/>
+          <p:cNvSpPr/>
+          <p:nvPr/>
+        </p:nvSpPr>
+        <p:spPr>
+          <a:xfrm>
+            <a:off x="3981450" y="3618905"/>
+            <a:ext cx="714375" cy="161925"/>
+          </a:xfrm>
+          <a:prstGeom prst="rect">
+            <a:avLst/>
+          </a:prstGeom>
+          <a:solidFill>
+            <a:srgbClr val="C8C8C4"/>
+          </a:solidFill>
+          <a:ln>
+            <a:noFill/>
+          </a:ln>
+          <a:effectLst/>
+        </p:spPr>
+        <p:style>
+          <a:lnRef idx="1">
+            <a:schemeClr val="accent1"/>
+          </a:lnRef>
+          <a:fillRef idx="3">
+            <a:schemeClr val="accent1"/>
+          </a:fillRef>
+          <a:effectRef idx="2">
+            <a:schemeClr val="accent1"/>
+          </a:effectRef>
+          <a:fontRef idx="minor">
+            <a:schemeClr val="lt1"/>
+          </a:fontRef>
+        </p:style>
+        <p:txBody>
+          <a:bodyPr rtlCol="0" anchor="ctr"/>
+          <a:lstStyle/>
+          <a:p>
+            <a:pPr algn="ctr"/>
+          </a:p>
+        </p:txBody>
+      </p:sp>
+      <p:sp>
+        <p:nvSpPr>
+          <p:cNvPr id="20" name="Rectangle 19"/>
+          <p:cNvSpPr/>
+          <p:nvPr/>
+        </p:nvSpPr>
+        <p:spPr>
+          <a:xfrm>
+            <a:off x="4695825" y="3618905"/>
+            <a:ext cx="785812" cy="161925"/>
+          </a:xfrm>
+          <a:prstGeom prst="rect">
+            <a:avLst/>
+          </a:prstGeom>
+          <a:solidFill>
+            <a:srgbClr val="D7263D"/>
+          </a:solidFill>
+          <a:ln>
+            <a:noFill/>
+          </a:ln>
+          <a:effectLst/>
+        </p:spPr>
+        <p:style>
+          <a:lnRef idx="1">
+            <a:schemeClr val="accent1"/>
+          </a:lnRef>
+          <a:fillRef idx="3">
+            <a:schemeClr val="accent1"/>
+          </a:fillRef>
+          <a:effectRef idx="2">
+            <a:schemeClr val="accent1"/>
+          </a:effectRef>
+          <a:fontRef idx="minor">
+            <a:schemeClr val="lt1"/>
+          </a:fontRef>
+        </p:style>
+        <p:txBody>
+          <a:bodyPr rtlCol="0" anchor="ctr"/>
+          <a:lstStyle/>
+          <a:p>
+            <a:pPr algn="ctr"/>
+          </a:p>
+        </p:txBody>
+      </p:sp>
+      <p:sp>
+        <p:nvSpPr>
+          <p:cNvPr id="21" name="TextBox 20"/>
           <p:cNvSpPr txBox="1"/>
           <p:nvPr/>
         </p:nvSpPr>
@@ -13028,7 +13204,7 @@
       </p:sp>
       <p:sp>
         <p:nvSpPr>
-          <p:cNvPr id="18" name="TextBox 17"/>
+          <p:cNvPr id="22" name="TextBox 21"/>
           <p:cNvSpPr txBox="1"/>
           <p:nvPr/>
         </p:nvSpPr>
@@ -13075,7 +13251,7 @@
       </p:sp>
       <p:sp>
         <p:nvSpPr>
-          <p:cNvPr id="19" name="TextBox 18"/>
+          <p:cNvPr id="23" name="TextBox 22"/>
           <p:cNvSpPr txBox="1"/>
           <p:nvPr/>
         </p:nvSpPr>
@@ -13122,7 +13298,7 @@
       </p:sp>
       <p:sp>
         <p:nvSpPr>
-          <p:cNvPr id="20" name="TextBox 19"/>
+          <p:cNvPr id="24" name="TextBox 23"/>
           <p:cNvSpPr txBox="1"/>
           <p:nvPr/>
         </p:nvSpPr>
@@ -13169,14 +13345,61 @@
       </p:sp>
       <p:sp>
         <p:nvSpPr>
-          <p:cNvPr id="21" name="TextBox 20"/>
-          <p:cNvSpPr txBox="1"/>
-          <p:nvPr/>
-        </p:nvSpPr>
-        <p:spPr>
-          <a:xfrm>
-            <a:off x="609600" y="1804392"/>
-            <a:ext cx="3335655" cy="200025"/>
+          <p:cNvPr id="25" name="TextBox 24"/>
+          <p:cNvSpPr txBox="1"/>
+          <p:nvPr/>
+        </p:nvSpPr>
+        <p:spPr>
+          <a:xfrm>
+            <a:off x="609600" y="1809155"/>
+            <a:ext cx="3335655" cy="180975"/>
+          </a:xfrm>
+          <a:prstGeom prst="rect">
+            <a:avLst/>
+          </a:prstGeom>
+          <a:noFill/>
+        </p:spPr>
+        <p:txBody>
+          <a:bodyPr wrap="square" lIns="0" rIns="0" tIns="0" bIns="0" anchor="t">
+            <a:noAutofit/>
+          </a:bodyPr>
+          <a:lstStyle/>
+          <a:p>
+            <a:pPr algn="l">
+              <a:lnSpc>
+                <a:spcPts val="1425"/>
+              </a:lnSpc>
+              <a:spcBef>
+                <a:spcPts val="0"/>
+              </a:spcBef>
+              <a:spcAft>
+                <a:spcPts val="0"/>
+              </a:spcAft>
+            </a:pPr>
+            <a:r>
+              <a:rPr sz="1200" b="0" i="0" u="none">
+                <a:solidFill>
+                  <a:srgbClr val="000000"/>
+                </a:solidFill>
+                <a:latin typeface="Arial"/>
+                <a:ea typeface="Arial"/>
+                <a:cs typeface="Arial"/>
+              </a:rPr>
+              <a:t>Charité – Universitätsmedizin Berlin</a:t>
+            </a:r>
+          </a:p>
+        </p:txBody>
+      </p:sp>
+      <p:sp>
+        <p:nvSpPr>
+          <p:cNvPr id="26" name="TextBox 25"/>
+          <p:cNvSpPr txBox="1"/>
+          <p:nvPr/>
+        </p:nvSpPr>
+        <p:spPr>
+          <a:xfrm>
+            <a:off x="7258050" y="1799630"/>
+            <a:ext cx="319906" cy="200025"/>
           </a:xfrm>
           <a:prstGeom prst="rect">
             <a:avLst/>
@@ -13201,7 +13424,7 @@
               </a:spcAft>
             </a:pPr>
             <a:r>
-              <a:rPr sz="1275" b="0" i="0" u="none">
+              <a:rPr sz="1200" b="1" i="0" u="none">
                 <a:solidFill>
                   <a:srgbClr val="000000"/>
                 </a:solidFill>
@@ -13209,46 +13432,46 @@
                 <a:ea typeface="Arial"/>
                 <a:cs typeface="Arial"/>
               </a:rPr>
-              <a:t>Center for Stroke Research Berlin (Charité)</a:t>
-            </a:r>
-          </a:p>
-        </p:txBody>
-      </p:sp>
-      <p:sp>
-        <p:nvSpPr>
-          <p:cNvPr id="22" name="TextBox 21"/>
-          <p:cNvSpPr txBox="1"/>
-          <p:nvPr/>
-        </p:nvSpPr>
-        <p:spPr>
-          <a:xfrm>
-            <a:off x="7829550" y="1799630"/>
-            <a:ext cx="338733" cy="209550"/>
-          </a:xfrm>
-          <a:prstGeom prst="rect">
-            <a:avLst/>
-          </a:prstGeom>
-          <a:noFill/>
-        </p:spPr>
-        <p:txBody>
-          <a:bodyPr wrap="square" lIns="0" rIns="0" tIns="0" bIns="0" anchor="t">
-            <a:noAutofit/>
-          </a:bodyPr>
-          <a:lstStyle/>
-          <a:p>
-            <a:pPr algn="l">
-              <a:lnSpc>
-                <a:spcPts val="1650"/>
-              </a:lnSpc>
-              <a:spcBef>
-                <a:spcPts val="0"/>
-              </a:spcBef>
-              <a:spcAft>
-                <a:spcPts val="0"/>
-              </a:spcAft>
-            </a:pPr>
-            <a:r>
-              <a:rPr sz="1275" b="1" i="0" u="none">
+              <a:t>4.4×</a:t>
+            </a:r>
+          </a:p>
+        </p:txBody>
+      </p:sp>
+      <p:sp>
+        <p:nvSpPr>
+          <p:cNvPr id="27" name="TextBox 26"/>
+          <p:cNvSpPr txBox="1"/>
+          <p:nvPr/>
+        </p:nvSpPr>
+        <p:spPr>
+          <a:xfrm>
+            <a:off x="609600" y="2066330"/>
+            <a:ext cx="3335655" cy="180975"/>
+          </a:xfrm>
+          <a:prstGeom prst="rect">
+            <a:avLst/>
+          </a:prstGeom>
+          <a:noFill/>
+        </p:spPr>
+        <p:txBody>
+          <a:bodyPr wrap="square" lIns="0" rIns="0" tIns="0" bIns="0" anchor="t">
+            <a:noAutofit/>
+          </a:bodyPr>
+          <a:lstStyle/>
+          <a:p>
+            <a:pPr algn="l">
+              <a:lnSpc>
+                <a:spcPts val="1425"/>
+              </a:lnSpc>
+              <a:spcBef>
+                <a:spcPts val="0"/>
+              </a:spcBef>
+              <a:spcAft>
+                <a:spcPts val="0"/>
+              </a:spcAft>
+            </a:pPr>
+            <a:r>
+              <a:rPr sz="1200" b="0" i="0" u="none">
                 <a:solidFill>
                   <a:srgbClr val="000000"/>
                 </a:solidFill>
@@ -13256,21 +13479,21 @@
                 <a:ea typeface="Arial"/>
                 <a:cs typeface="Arial"/>
               </a:rPr>
-              <a:t>5.2×</a:t>
-            </a:r>
-          </a:p>
-        </p:txBody>
-      </p:sp>
-      <p:sp>
-        <p:nvSpPr>
-          <p:cNvPr id="23" name="TextBox 22"/>
-          <p:cNvSpPr txBox="1"/>
-          <p:nvPr/>
-        </p:nvSpPr>
-        <p:spPr>
-          <a:xfrm>
-            <a:off x="609600" y="2099667"/>
-            <a:ext cx="3335655" cy="200025"/>
+              <a:t>University of Oxford</a:t>
+            </a:r>
+          </a:p>
+        </p:txBody>
+      </p:sp>
+      <p:sp>
+        <p:nvSpPr>
+          <p:cNvPr id="28" name="TextBox 27"/>
+          <p:cNvSpPr txBox="1"/>
+          <p:nvPr/>
+        </p:nvSpPr>
+        <p:spPr>
+          <a:xfrm>
+            <a:off x="6186488" y="2056805"/>
+            <a:ext cx="319906" cy="200025"/>
           </a:xfrm>
           <a:prstGeom prst="rect">
             <a:avLst/>
@@ -13295,7 +13518,7 @@
               </a:spcAft>
             </a:pPr>
             <a:r>
-              <a:rPr sz="1275" b="0" i="0" u="none">
+              <a:rPr sz="1200" b="1" i="0" u="none">
                 <a:solidFill>
                   <a:srgbClr val="000000"/>
                 </a:solidFill>
@@ -13303,46 +13526,46 @@
                 <a:ea typeface="Arial"/>
                 <a:cs typeface="Arial"/>
               </a:rPr>
-              <a:t>Charité, Berlin</a:t>
-            </a:r>
-          </a:p>
-        </p:txBody>
-      </p:sp>
-      <p:sp>
-        <p:nvSpPr>
-          <p:cNvPr id="24" name="TextBox 23"/>
-          <p:cNvSpPr txBox="1"/>
-          <p:nvPr/>
-        </p:nvSpPr>
-        <p:spPr>
-          <a:xfrm>
-            <a:off x="7258050" y="2094905"/>
-            <a:ext cx="338733" cy="209550"/>
-          </a:xfrm>
-          <a:prstGeom prst="rect">
-            <a:avLst/>
-          </a:prstGeom>
-          <a:noFill/>
-        </p:spPr>
-        <p:txBody>
-          <a:bodyPr wrap="square" lIns="0" rIns="0" tIns="0" bIns="0" anchor="t">
-            <a:noAutofit/>
-          </a:bodyPr>
-          <a:lstStyle/>
-          <a:p>
-            <a:pPr algn="l">
-              <a:lnSpc>
-                <a:spcPts val="1650"/>
-              </a:lnSpc>
-              <a:spcBef>
-                <a:spcPts val="0"/>
-              </a:spcBef>
-              <a:spcAft>
-                <a:spcPts val="0"/>
-              </a:spcAft>
-            </a:pPr>
-            <a:r>
-              <a:rPr sz="1275" b="1" i="0" u="none">
+              <a:t>2.9×</a:t>
+            </a:r>
+          </a:p>
+        </p:txBody>
+      </p:sp>
+      <p:sp>
+        <p:nvSpPr>
+          <p:cNvPr id="29" name="TextBox 28"/>
+          <p:cNvSpPr txBox="1"/>
+          <p:nvPr/>
+        </p:nvSpPr>
+        <p:spPr>
+          <a:xfrm>
+            <a:off x="609600" y="2323505"/>
+            <a:ext cx="3335655" cy="180975"/>
+          </a:xfrm>
+          <a:prstGeom prst="rect">
+            <a:avLst/>
+          </a:prstGeom>
+          <a:noFill/>
+        </p:spPr>
+        <p:txBody>
+          <a:bodyPr wrap="square" lIns="0" rIns="0" tIns="0" bIns="0" anchor="t">
+            <a:noAutofit/>
+          </a:bodyPr>
+          <a:lstStyle/>
+          <a:p>
+            <a:pPr algn="l">
+              <a:lnSpc>
+                <a:spcPts val="1425"/>
+              </a:lnSpc>
+              <a:spcBef>
+                <a:spcPts val="0"/>
+              </a:spcBef>
+              <a:spcAft>
+                <a:spcPts val="0"/>
+              </a:spcAft>
+            </a:pPr>
+            <a:r>
+              <a:rPr sz="1200" b="0" i="0" u="none">
                 <a:solidFill>
                   <a:srgbClr val="000000"/>
                 </a:solidFill>
@@ -13350,21 +13573,21 @@
                 <a:ea typeface="Arial"/>
                 <a:cs typeface="Arial"/>
               </a:rPr>
-              <a:t>4.4×</a:t>
-            </a:r>
-          </a:p>
-        </p:txBody>
-      </p:sp>
-      <p:sp>
-        <p:nvSpPr>
-          <p:cNvPr id="25" name="TextBox 24"/>
-          <p:cNvSpPr txBox="1"/>
-          <p:nvPr/>
-        </p:nvSpPr>
-        <p:spPr>
-          <a:xfrm>
-            <a:off x="609600" y="2394942"/>
-            <a:ext cx="3335655" cy="200025"/>
+              <a:t>UKE Hamburg-Eppendorf</a:t>
+            </a:r>
+          </a:p>
+        </p:txBody>
+      </p:sp>
+      <p:sp>
+        <p:nvSpPr>
+          <p:cNvPr id="30" name="TextBox 29"/>
+          <p:cNvSpPr txBox="1"/>
+          <p:nvPr/>
+        </p:nvSpPr>
+        <p:spPr>
+          <a:xfrm>
+            <a:off x="5972175" y="2313980"/>
+            <a:ext cx="319906" cy="200025"/>
           </a:xfrm>
           <a:prstGeom prst="rect">
             <a:avLst/>
@@ -13389,7 +13612,7 @@
               </a:spcAft>
             </a:pPr>
             <a:r>
-              <a:rPr sz="1275" b="0" i="0" u="none">
+              <a:rPr sz="1200" b="1" i="0" u="none">
                 <a:solidFill>
                   <a:srgbClr val="000000"/>
                 </a:solidFill>
@@ -13397,46 +13620,46 @@
                 <a:ea typeface="Arial"/>
                 <a:cs typeface="Arial"/>
               </a:rPr>
-              <a:t>University of Oxford</a:t>
-            </a:r>
-          </a:p>
-        </p:txBody>
-      </p:sp>
-      <p:sp>
-        <p:nvSpPr>
-          <p:cNvPr id="26" name="TextBox 25"/>
-          <p:cNvSpPr txBox="1"/>
-          <p:nvPr/>
-        </p:nvSpPr>
-        <p:spPr>
-          <a:xfrm>
-            <a:off x="6186488" y="2390180"/>
-            <a:ext cx="338733" cy="209550"/>
-          </a:xfrm>
-          <a:prstGeom prst="rect">
-            <a:avLst/>
-          </a:prstGeom>
-          <a:noFill/>
-        </p:spPr>
-        <p:txBody>
-          <a:bodyPr wrap="square" lIns="0" rIns="0" tIns="0" bIns="0" anchor="t">
-            <a:noAutofit/>
-          </a:bodyPr>
-          <a:lstStyle/>
-          <a:p>
-            <a:pPr algn="l">
-              <a:lnSpc>
-                <a:spcPts val="1650"/>
-              </a:lnSpc>
-              <a:spcBef>
-                <a:spcPts val="0"/>
-              </a:spcBef>
-              <a:spcAft>
-                <a:spcPts val="0"/>
-              </a:spcAft>
-            </a:pPr>
-            <a:r>
-              <a:rPr sz="1275" b="1" i="0" u="none">
+              <a:t>2.6×</a:t>
+            </a:r>
+          </a:p>
+        </p:txBody>
+      </p:sp>
+      <p:sp>
+        <p:nvSpPr>
+          <p:cNvPr id="31" name="TextBox 30"/>
+          <p:cNvSpPr txBox="1"/>
+          <p:nvPr/>
+        </p:nvSpPr>
+        <p:spPr>
+          <a:xfrm>
+            <a:off x="609600" y="2580680"/>
+            <a:ext cx="3335655" cy="180975"/>
+          </a:xfrm>
+          <a:prstGeom prst="rect">
+            <a:avLst/>
+          </a:prstGeom>
+          <a:noFill/>
+        </p:spPr>
+        <p:txBody>
+          <a:bodyPr wrap="square" lIns="0" rIns="0" tIns="0" bIns="0" anchor="t">
+            <a:noAutofit/>
+          </a:bodyPr>
+          <a:lstStyle/>
+          <a:p>
+            <a:pPr algn="l">
+              <a:lnSpc>
+                <a:spcPts val="1425"/>
+              </a:lnSpc>
+              <a:spcBef>
+                <a:spcPts val="0"/>
+              </a:spcBef>
+              <a:spcAft>
+                <a:spcPts val="0"/>
+              </a:spcAft>
+            </a:pPr>
+            <a:r>
+              <a:rPr sz="1200" b="0" i="0" u="none">
                 <a:solidFill>
                   <a:srgbClr val="000000"/>
                 </a:solidFill>
@@ -13444,21 +13667,21 @@
                 <a:ea typeface="Arial"/>
                 <a:cs typeface="Arial"/>
               </a:rPr>
-              <a:t>2.9×</a:t>
-            </a:r>
-          </a:p>
-        </p:txBody>
-      </p:sp>
-      <p:sp>
-        <p:nvSpPr>
-          <p:cNvPr id="27" name="TextBox 26"/>
-          <p:cNvSpPr txBox="1"/>
-          <p:nvPr/>
-        </p:nvSpPr>
-        <p:spPr>
-          <a:xfrm>
-            <a:off x="609600" y="2690217"/>
-            <a:ext cx="3335655" cy="200025"/>
+              <a:t>University of Edinburgh</a:t>
+            </a:r>
+          </a:p>
+        </p:txBody>
+      </p:sp>
+      <p:sp>
+        <p:nvSpPr>
+          <p:cNvPr id="32" name="TextBox 31"/>
+          <p:cNvSpPr txBox="1"/>
+          <p:nvPr/>
+        </p:nvSpPr>
+        <p:spPr>
+          <a:xfrm>
+            <a:off x="5900738" y="2571155"/>
+            <a:ext cx="319906" cy="200025"/>
           </a:xfrm>
           <a:prstGeom prst="rect">
             <a:avLst/>
@@ -13483,7 +13706,7 @@
               </a:spcAft>
             </a:pPr>
             <a:r>
-              <a:rPr sz="1275" b="0" i="0" u="none">
+              <a:rPr sz="1200" b="1" i="0" u="none">
                 <a:solidFill>
                   <a:srgbClr val="000000"/>
                 </a:solidFill>
@@ -13491,46 +13714,46 @@
                 <a:ea typeface="Arial"/>
                 <a:cs typeface="Arial"/>
               </a:rPr>
-              <a:t>UKE Hamburg-Eppendorf</a:t>
-            </a:r>
-          </a:p>
-        </p:txBody>
-      </p:sp>
-      <p:sp>
-        <p:nvSpPr>
-          <p:cNvPr id="28" name="TextBox 27"/>
-          <p:cNvSpPr txBox="1"/>
-          <p:nvPr/>
-        </p:nvSpPr>
-        <p:spPr>
-          <a:xfrm>
-            <a:off x="5972175" y="2685455"/>
-            <a:ext cx="338733" cy="209550"/>
-          </a:xfrm>
-          <a:prstGeom prst="rect">
-            <a:avLst/>
-          </a:prstGeom>
-          <a:noFill/>
-        </p:spPr>
-        <p:txBody>
-          <a:bodyPr wrap="square" lIns="0" rIns="0" tIns="0" bIns="0" anchor="t">
-            <a:noAutofit/>
-          </a:bodyPr>
-          <a:lstStyle/>
-          <a:p>
-            <a:pPr algn="l">
-              <a:lnSpc>
-                <a:spcPts val="1650"/>
-              </a:lnSpc>
-              <a:spcBef>
-                <a:spcPts val="0"/>
-              </a:spcBef>
-              <a:spcAft>
-                <a:spcPts val="0"/>
-              </a:spcAft>
-            </a:pPr>
-            <a:r>
-              <a:rPr sz="1275" b="1" i="0" u="none">
+              <a:t>2.5×</a:t>
+            </a:r>
+          </a:p>
+        </p:txBody>
+      </p:sp>
+      <p:sp>
+        <p:nvSpPr>
+          <p:cNvPr id="33" name="TextBox 32"/>
+          <p:cNvSpPr txBox="1"/>
+          <p:nvPr/>
+        </p:nvSpPr>
+        <p:spPr>
+          <a:xfrm>
+            <a:off x="609600" y="2837855"/>
+            <a:ext cx="3335655" cy="180975"/>
+          </a:xfrm>
+          <a:prstGeom prst="rect">
+            <a:avLst/>
+          </a:prstGeom>
+          <a:noFill/>
+        </p:spPr>
+        <p:txBody>
+          <a:bodyPr wrap="square" lIns="0" rIns="0" tIns="0" bIns="0" anchor="t">
+            <a:noAutofit/>
+          </a:bodyPr>
+          <a:lstStyle/>
+          <a:p>
+            <a:pPr algn="l">
+              <a:lnSpc>
+                <a:spcPts val="1425"/>
+              </a:lnSpc>
+              <a:spcBef>
+                <a:spcPts val="0"/>
+              </a:spcBef>
+              <a:spcAft>
+                <a:spcPts val="0"/>
+              </a:spcAft>
+            </a:pPr>
+            <a:r>
+              <a:rPr sz="1200" b="0" i="0" u="none">
                 <a:solidFill>
                   <a:srgbClr val="000000"/>
                 </a:solidFill>
@@ -13538,21 +13761,21 @@
                 <a:ea typeface="Arial"/>
                 <a:cs typeface="Arial"/>
               </a:rPr>
-              <a:t>2.6×</a:t>
-            </a:r>
-          </a:p>
-        </p:txBody>
-      </p:sp>
-      <p:sp>
-        <p:nvSpPr>
-          <p:cNvPr id="29" name="TextBox 28"/>
-          <p:cNvSpPr txBox="1"/>
-          <p:nvPr/>
-        </p:nvSpPr>
-        <p:spPr>
-          <a:xfrm>
-            <a:off x="609600" y="2985492"/>
-            <a:ext cx="3335655" cy="200025"/>
+              <a:t>Stanford University</a:t>
+            </a:r>
+          </a:p>
+        </p:txBody>
+      </p:sp>
+      <p:sp>
+        <p:nvSpPr>
+          <p:cNvPr id="34" name="TextBox 33"/>
+          <p:cNvSpPr txBox="1"/>
+          <p:nvPr/>
+        </p:nvSpPr>
+        <p:spPr>
+          <a:xfrm>
+            <a:off x="5757862" y="2828330"/>
+            <a:ext cx="319906" cy="200025"/>
           </a:xfrm>
           <a:prstGeom prst="rect">
             <a:avLst/>
@@ -13577,7 +13800,7 @@
               </a:spcAft>
             </a:pPr>
             <a:r>
-              <a:rPr sz="1275" b="0" i="0" u="none">
+              <a:rPr sz="1200" b="1" i="0" u="none">
                 <a:solidFill>
                   <a:srgbClr val="000000"/>
                 </a:solidFill>
@@ -13585,46 +13808,46 @@
                 <a:ea typeface="Arial"/>
                 <a:cs typeface="Arial"/>
               </a:rPr>
-              <a:t>University of Edinburgh</a:t>
-            </a:r>
-          </a:p>
-        </p:txBody>
-      </p:sp>
-      <p:sp>
-        <p:nvSpPr>
-          <p:cNvPr id="30" name="TextBox 29"/>
-          <p:cNvSpPr txBox="1"/>
-          <p:nvPr/>
-        </p:nvSpPr>
-        <p:spPr>
-          <a:xfrm>
-            <a:off x="5900738" y="2980730"/>
-            <a:ext cx="338733" cy="209550"/>
-          </a:xfrm>
-          <a:prstGeom prst="rect">
-            <a:avLst/>
-          </a:prstGeom>
-          <a:noFill/>
-        </p:spPr>
-        <p:txBody>
-          <a:bodyPr wrap="square" lIns="0" rIns="0" tIns="0" bIns="0" anchor="t">
-            <a:noAutofit/>
-          </a:bodyPr>
-          <a:lstStyle/>
-          <a:p>
-            <a:pPr algn="l">
-              <a:lnSpc>
-                <a:spcPts val="1650"/>
-              </a:lnSpc>
-              <a:spcBef>
-                <a:spcPts val="0"/>
-              </a:spcBef>
-              <a:spcAft>
-                <a:spcPts val="0"/>
-              </a:spcAft>
-            </a:pPr>
-            <a:r>
-              <a:rPr sz="1275" b="1" i="0" u="none">
+              <a:t>2.3×</a:t>
+            </a:r>
+          </a:p>
+        </p:txBody>
+      </p:sp>
+      <p:sp>
+        <p:nvSpPr>
+          <p:cNvPr id="35" name="TextBox 34"/>
+          <p:cNvSpPr txBox="1"/>
+          <p:nvPr/>
+        </p:nvSpPr>
+        <p:spPr>
+          <a:xfrm>
+            <a:off x="609600" y="3095030"/>
+            <a:ext cx="3335655" cy="180975"/>
+          </a:xfrm>
+          <a:prstGeom prst="rect">
+            <a:avLst/>
+          </a:prstGeom>
+          <a:noFill/>
+        </p:spPr>
+        <p:txBody>
+          <a:bodyPr wrap="square" lIns="0" rIns="0" tIns="0" bIns="0" anchor="t">
+            <a:noAutofit/>
+          </a:bodyPr>
+          <a:lstStyle/>
+          <a:p>
+            <a:pPr algn="l">
+              <a:lnSpc>
+                <a:spcPts val="1425"/>
+              </a:lnSpc>
+              <a:spcBef>
+                <a:spcPts val="0"/>
+              </a:spcBef>
+              <a:spcAft>
+                <a:spcPts val="0"/>
+              </a:spcAft>
+            </a:pPr>
+            <a:r>
+              <a:rPr sz="1200" b="0" i="0" u="none">
                 <a:solidFill>
                   <a:srgbClr val="000000"/>
                 </a:solidFill>
@@ -13632,21 +13855,21 @@
                 <a:ea typeface="Arial"/>
                 <a:cs typeface="Arial"/>
               </a:rPr>
-              <a:t>2.5×</a:t>
-            </a:r>
-          </a:p>
-        </p:txBody>
-      </p:sp>
-      <p:sp>
-        <p:nvSpPr>
-          <p:cNvPr id="31" name="TextBox 30"/>
-          <p:cNvSpPr txBox="1"/>
-          <p:nvPr/>
-        </p:nvSpPr>
-        <p:spPr>
-          <a:xfrm>
-            <a:off x="609600" y="3280767"/>
-            <a:ext cx="3335655" cy="200025"/>
+              <a:t>University of Nottingham</a:t>
+            </a:r>
+          </a:p>
+        </p:txBody>
+      </p:sp>
+      <p:sp>
+        <p:nvSpPr>
+          <p:cNvPr id="36" name="TextBox 35"/>
+          <p:cNvSpPr txBox="1"/>
+          <p:nvPr/>
+        </p:nvSpPr>
+        <p:spPr>
+          <a:xfrm>
+            <a:off x="5686425" y="3085505"/>
+            <a:ext cx="319906" cy="200025"/>
           </a:xfrm>
           <a:prstGeom prst="rect">
             <a:avLst/>
@@ -13671,7 +13894,7 @@
               </a:spcAft>
             </a:pPr>
             <a:r>
-              <a:rPr sz="1275" b="0" i="0" u="none">
+              <a:rPr sz="1200" b="1" i="0" u="none">
                 <a:solidFill>
                   <a:srgbClr val="000000"/>
                 </a:solidFill>
@@ -13679,46 +13902,46 @@
                 <a:ea typeface="Arial"/>
                 <a:cs typeface="Arial"/>
               </a:rPr>
-              <a:t>Stanford University</a:t>
-            </a:r>
-          </a:p>
-        </p:txBody>
-      </p:sp>
-      <p:sp>
-        <p:nvSpPr>
-          <p:cNvPr id="32" name="TextBox 31"/>
-          <p:cNvSpPr txBox="1"/>
-          <p:nvPr/>
-        </p:nvSpPr>
-        <p:spPr>
-          <a:xfrm>
-            <a:off x="5757862" y="3276005"/>
-            <a:ext cx="338733" cy="209550"/>
-          </a:xfrm>
-          <a:prstGeom prst="rect">
-            <a:avLst/>
-          </a:prstGeom>
-          <a:noFill/>
-        </p:spPr>
-        <p:txBody>
-          <a:bodyPr wrap="square" lIns="0" rIns="0" tIns="0" bIns="0" anchor="t">
-            <a:noAutofit/>
-          </a:bodyPr>
-          <a:lstStyle/>
-          <a:p>
-            <a:pPr algn="l">
-              <a:lnSpc>
-                <a:spcPts val="1650"/>
-              </a:lnSpc>
-              <a:spcBef>
-                <a:spcPts val="0"/>
-              </a:spcBef>
-              <a:spcAft>
-                <a:spcPts val="0"/>
-              </a:spcAft>
-            </a:pPr>
-            <a:r>
-              <a:rPr sz="1275" b="1" i="0" u="none">
+              <a:t>2.2×</a:t>
+            </a:r>
+          </a:p>
+        </p:txBody>
+      </p:sp>
+      <p:sp>
+        <p:nvSpPr>
+          <p:cNvPr id="37" name="TextBox 36"/>
+          <p:cNvSpPr txBox="1"/>
+          <p:nvPr/>
+        </p:nvSpPr>
+        <p:spPr>
+          <a:xfrm>
+            <a:off x="609600" y="3352205"/>
+            <a:ext cx="3335655" cy="180975"/>
+          </a:xfrm>
+          <a:prstGeom prst="rect">
+            <a:avLst/>
+          </a:prstGeom>
+          <a:noFill/>
+        </p:spPr>
+        <p:txBody>
+          <a:bodyPr wrap="square" lIns="0" rIns="0" tIns="0" bIns="0" anchor="t">
+            <a:noAutofit/>
+          </a:bodyPr>
+          <a:lstStyle/>
+          <a:p>
+            <a:pPr algn="l">
+              <a:lnSpc>
+                <a:spcPts val="1425"/>
+              </a:lnSpc>
+              <a:spcBef>
+                <a:spcPts val="0"/>
+              </a:spcBef>
+              <a:spcAft>
+                <a:spcPts val="0"/>
+              </a:spcAft>
+            </a:pPr>
+            <a:r>
+              <a:rPr sz="1200" b="0" i="0" u="none">
                 <a:solidFill>
                   <a:srgbClr val="000000"/>
                 </a:solidFill>
@@ -13726,20 +13949,161 @@
                 <a:ea typeface="Arial"/>
                 <a:cs typeface="Arial"/>
               </a:rPr>
-              <a:t>2.3×</a:t>
-            </a:r>
-          </a:p>
-        </p:txBody>
-      </p:sp>
-      <p:sp>
-        <p:nvSpPr>
-          <p:cNvPr id="33" name="TextBox 32"/>
-          <p:cNvSpPr txBox="1"/>
-          <p:nvPr/>
-        </p:nvSpPr>
-        <p:spPr>
-          <a:xfrm>
-            <a:off x="609600" y="3637955"/>
+              <a:t>Massachusetts General Hospital</a:t>
+            </a:r>
+          </a:p>
+        </p:txBody>
+      </p:sp>
+      <p:sp>
+        <p:nvSpPr>
+          <p:cNvPr id="38" name="TextBox 37"/>
+          <p:cNvSpPr txBox="1"/>
+          <p:nvPr/>
+        </p:nvSpPr>
+        <p:spPr>
+          <a:xfrm>
+            <a:off x="5686425" y="3342680"/>
+            <a:ext cx="319906" cy="200025"/>
+          </a:xfrm>
+          <a:prstGeom prst="rect">
+            <a:avLst/>
+          </a:prstGeom>
+          <a:noFill/>
+        </p:spPr>
+        <p:txBody>
+          <a:bodyPr wrap="square" lIns="0" rIns="0" tIns="0" bIns="0" anchor="t">
+            <a:noAutofit/>
+          </a:bodyPr>
+          <a:lstStyle/>
+          <a:p>
+            <a:pPr algn="l">
+              <a:lnSpc>
+                <a:spcPts val="1575"/>
+              </a:lnSpc>
+              <a:spcBef>
+                <a:spcPts val="0"/>
+              </a:spcBef>
+              <a:spcAft>
+                <a:spcPts val="0"/>
+              </a:spcAft>
+            </a:pPr>
+            <a:r>
+              <a:rPr sz="1200" b="1" i="0" u="none">
+                <a:solidFill>
+                  <a:srgbClr val="000000"/>
+                </a:solidFill>
+                <a:latin typeface="Arial"/>
+                <a:ea typeface="Arial"/>
+                <a:cs typeface="Arial"/>
+              </a:rPr>
+              <a:t>2.2×</a:t>
+            </a:r>
+          </a:p>
+        </p:txBody>
+      </p:sp>
+      <p:sp>
+        <p:nvSpPr>
+          <p:cNvPr id="39" name="TextBox 38"/>
+          <p:cNvSpPr txBox="1"/>
+          <p:nvPr/>
+        </p:nvSpPr>
+        <p:spPr>
+          <a:xfrm>
+            <a:off x="609600" y="3609380"/>
+            <a:ext cx="3335655" cy="180975"/>
+          </a:xfrm>
+          <a:prstGeom prst="rect">
+            <a:avLst/>
+          </a:prstGeom>
+          <a:noFill/>
+        </p:spPr>
+        <p:txBody>
+          <a:bodyPr wrap="square" lIns="0" rIns="0" tIns="0" bIns="0" anchor="t">
+            <a:noAutofit/>
+          </a:bodyPr>
+          <a:lstStyle/>
+          <a:p>
+            <a:pPr algn="l">
+              <a:lnSpc>
+                <a:spcPts val="1425"/>
+              </a:lnSpc>
+              <a:spcBef>
+                <a:spcPts val="0"/>
+              </a:spcBef>
+              <a:spcAft>
+                <a:spcPts val="0"/>
+              </a:spcAft>
+            </a:pPr>
+            <a:r>
+              <a:rPr sz="1200" b="0" i="0" u="none">
+                <a:solidFill>
+                  <a:srgbClr val="000000"/>
+                </a:solidFill>
+                <a:latin typeface="Arial"/>
+                <a:ea typeface="Arial"/>
+                <a:cs typeface="Arial"/>
+              </a:rPr>
+              <a:t>University of Glasgow</a:t>
+            </a:r>
+          </a:p>
+        </p:txBody>
+      </p:sp>
+      <p:sp>
+        <p:nvSpPr>
+          <p:cNvPr id="40" name="TextBox 39"/>
+          <p:cNvSpPr txBox="1"/>
+          <p:nvPr/>
+        </p:nvSpPr>
+        <p:spPr>
+          <a:xfrm>
+            <a:off x="5614988" y="3599855"/>
+            <a:ext cx="319906" cy="200025"/>
+          </a:xfrm>
+          <a:prstGeom prst="rect">
+            <a:avLst/>
+          </a:prstGeom>
+          <a:noFill/>
+        </p:spPr>
+        <p:txBody>
+          <a:bodyPr wrap="square" lIns="0" rIns="0" tIns="0" bIns="0" anchor="t">
+            <a:noAutofit/>
+          </a:bodyPr>
+          <a:lstStyle/>
+          <a:p>
+            <a:pPr algn="l">
+              <a:lnSpc>
+                <a:spcPts val="1575"/>
+              </a:lnSpc>
+              <a:spcBef>
+                <a:spcPts val="0"/>
+              </a:spcBef>
+              <a:spcAft>
+                <a:spcPts val="0"/>
+              </a:spcAft>
+            </a:pPr>
+            <a:r>
+              <a:rPr sz="1200" b="1" i="0" u="none">
+                <a:solidFill>
+                  <a:srgbClr val="000000"/>
+                </a:solidFill>
+                <a:latin typeface="Arial"/>
+                <a:ea typeface="Arial"/>
+                <a:cs typeface="Arial"/>
+              </a:rPr>
+              <a:t>2.1×</a:t>
+            </a:r>
+          </a:p>
+        </p:txBody>
+      </p:sp>
+      <p:sp>
+        <p:nvSpPr>
+          <p:cNvPr id="41" name="TextBox 40"/>
+          <p:cNvSpPr txBox="1"/>
+          <p:nvPr/>
+        </p:nvSpPr>
+        <p:spPr>
+          <a:xfrm>
+            <a:off x="609600" y="3952280"/>
             <a:ext cx="8162544" cy="185738"/>
           </a:xfrm>
           <a:prstGeom prst="rect">

</xml_diff>